<commit_message>
Complete RepoPilot project and pitch deck
</commit_message>
<xml_diff>
--- a/docs/RepoPilot_Epchoesque2_PitchDeck_new.pptx
+++ b/docs/RepoPilot_Epchoesque2_PitchDeck_new.pptx
@@ -266,19 +266,19 @@
 <pc:chgInfo xmlns:a="http://schemas.openxmlformats.org/drawingml/2006/main" xmlns:r="http://schemas.openxmlformats.org/officeDocument/2006/relationships" xmlns:ac="http://schemas.microsoft.com/office/drawing/2013/main/command" xmlns:pc="http://schemas.microsoft.com/office/powerpoint/2013/main/command">
   <pc:docChgLst>
     <pc:chgData name="Siddhant Asati" userId="f714eb6b166d2c65" providerId="LiveId" clId="{2F15454B-8AC4-4A74-A40A-4746D4B03782}"/>
-    <pc:docChg chg="modSld">
-      <pc:chgData name="Siddhant Asati" userId="f714eb6b166d2c65" providerId="LiveId" clId="{2F15454B-8AC4-4A74-A40A-4746D4B03782}" dt="2026-09-18T05:43:01.632" v="58" actId="20577"/>
+    <pc:docChg chg="custSel modSld">
+      <pc:chgData name="Siddhant Asati" userId="f714eb6b166d2c65" providerId="LiveId" clId="{2F15454B-8AC4-4A74-A40A-4746D4B03782}" dt="2026-09-18T05:45:40.934" v="113" actId="14100"/>
       <pc:docMkLst>
         <pc:docMk/>
       </pc:docMkLst>
       <pc:sldChg chg="modSp mod">
-        <pc:chgData name="Siddhant Asati" userId="f714eb6b166d2c65" providerId="LiveId" clId="{2F15454B-8AC4-4A74-A40A-4746D4B03782}" dt="2026-09-18T05:43:01.632" v="58" actId="20577"/>
+        <pc:chgData name="Siddhant Asati" userId="f714eb6b166d2c65" providerId="LiveId" clId="{2F15454B-8AC4-4A74-A40A-4746D4B03782}" dt="2026-09-18T05:45:40.934" v="113" actId="14100"/>
         <pc:sldMkLst>
           <pc:docMk/>
           <pc:sldMk cId="0" sldId="256"/>
         </pc:sldMkLst>
         <pc:spChg chg="mod">
-          <ac:chgData name="Siddhant Asati" userId="f714eb6b166d2c65" providerId="LiveId" clId="{2F15454B-8AC4-4A74-A40A-4746D4B03782}" dt="2026-09-18T05:43:01.632" v="58" actId="20577"/>
+          <ac:chgData name="Siddhant Asati" userId="f714eb6b166d2c65" providerId="LiveId" clId="{2F15454B-8AC4-4A74-A40A-4746D4B03782}" dt="2026-09-18T05:45:40.934" v="113" actId="14100"/>
           <ac:spMkLst>
             <pc:docMk/>
             <pc:sldMk cId="0" sldId="256"/>
@@ -11977,8 +11977,8 @@
         </p:nvSpPr>
         <p:spPr>
           <a:xfrm>
-            <a:off x="2286000" y="4828032"/>
-            <a:ext cx="7498079" cy="153888"/>
+            <a:off x="1101214" y="4751762"/>
+            <a:ext cx="9566786" cy="161583"/>
           </a:xfrm>
           <a:prstGeom prst="rect">
             <a:avLst/>
@@ -11993,7 +11993,7 @@
           <a:p>
             <a:pPr algn="ctr"/>
             <a:r>
-              <a:rPr sz="1000" b="0" dirty="0">
+              <a:rPr sz="1050" b="0" dirty="0">
                 <a:solidFill>
                   <a:srgbClr val="5B6370"/>
                 </a:solidFill>
@@ -12002,7 +12002,7 @@
               <a:t>Team: </a:t>
             </a:r>
             <a:r>
-              <a:rPr lang="en-US" sz="1000" dirty="0">
+              <a:rPr lang="en-US" sz="1050" dirty="0">
                 <a:solidFill>
                   <a:srgbClr val="5B6370"/>
                 </a:solidFill>
@@ -12010,7 +12010,7 @@
               <a:t>Aman Tyagi</a:t>
             </a:r>
             <a:r>
-              <a:rPr sz="1000" b="0" dirty="0">
+              <a:rPr sz="1050" b="0" dirty="0">
                 <a:solidFill>
                   <a:srgbClr val="5B6370"/>
                 </a:solidFill>
@@ -12019,7 +12019,7 @@
               <a:t> — Agent Brain  |  </a:t>
             </a:r>
             <a:r>
-              <a:rPr lang="en-US" sz="1000" dirty="0">
+              <a:rPr lang="en-US" sz="1050" dirty="0">
                 <a:solidFill>
                   <a:srgbClr val="5B6370"/>
                 </a:solidFill>
@@ -12027,7 +12027,7 @@
               <a:t>Sahaj Kumar</a:t>
             </a:r>
             <a:r>
-              <a:rPr sz="1000" b="0" dirty="0">
+              <a:rPr sz="1050" b="0" dirty="0">
                 <a:solidFill>
                   <a:srgbClr val="5B6370"/>
                 </a:solidFill>
@@ -12036,7 +12036,7 @@
               <a:t> — Tools &amp; Security  |  </a:t>
             </a:r>
             <a:r>
-              <a:rPr lang="en-US" sz="1000" dirty="0">
+              <a:rPr lang="en-US" sz="1050" dirty="0">
                 <a:solidFill>
                   <a:srgbClr val="5B6370"/>
                 </a:solidFill>
@@ -12044,7 +12044,7 @@
               <a:t>Siddhant Asati</a:t>
             </a:r>
             <a:r>
-              <a:rPr sz="1000" b="0" dirty="0">
+              <a:rPr sz="1050" b="0" dirty="0">
                 <a:solidFill>
                   <a:srgbClr val="5B6370"/>
                 </a:solidFill>
@@ -12052,6 +12052,21 @@
               </a:rPr>
               <a:t> — Frontend, API &amp; Demo</a:t>
             </a:r>
+            <a:r>
+              <a:rPr lang="en-US" sz="1050" b="0" dirty="0">
+                <a:solidFill>
+                  <a:srgbClr val="5B6370"/>
+                </a:solidFill>
+                <a:latin typeface="Arial" panose="020B0604020202020204"/>
+              </a:rPr>
+              <a:t> | Amey Bondre – Improving UI/UX, PPT</a:t>
+            </a:r>
+            <a:endParaRPr sz="1050" b="0" dirty="0">
+              <a:solidFill>
+                <a:srgbClr val="5B6370"/>
+              </a:solidFill>
+              <a:latin typeface="Arial" panose="020B0604020202020204"/>
+            </a:endParaRPr>
           </a:p>
         </p:txBody>
       </p:sp>

</xml_diff>